<commit_message>
Rewrite closing slide benefits in the client's wording.
Keep the four roles and simplify the dictated value points for worker, curator, H&S specialist, and CEO.

Co-authored-by: lysakalenushka-hash <lysakalenushka-hash@users.noreply.github.com>
</commit_message>
<xml_diff>
--- a/issledovaniya/Lab-Intellekt_prodayushchaya-prezentaciya_v2.pptx
+++ b/issledovaniya/Lab-Intellekt_prodayushchaya-prezentaciya_v2.pptx
@@ -8733,8 +8733,8 @@
           <p:nvPr/>
         </p:nvGraphicFramePr>
         <p:xfrm>
-          <a:off x="420000" y="1450000"/>
-          <a:ext cx="11350000" cy="4900000"/>
+          <a:off x="420000" y="1480000"/>
+          <a:ext cx="11350000" cy="4820000"/>
         </p:xfrm>
         <a:graphic>
           <a:graphicData uri="http://schemas.openxmlformats.org/drawingml/2006/table">
@@ -8748,15 +8748,19 @@
                 <a:gridCol w="2837500"/>
                 <a:gridCol w="2837500"/>
               </a:tblGrid>
-              <a:tr h="760000">
+              <a:tr h="820000">
                 <a:tc>
                   <a:txBody>
                     <a:bodyPr wrap="square"/>
                     <a:lstStyle/>
                     <a:p>
-                      <a:pPr algn="l"/>
+                      <a:pPr algn="l">
+                        <a:spcAft>
+                          <a:spcPts val="600"/>
+                        </a:spcAft>
+                      </a:pPr>
                       <a:r>
-                        <a:rPr sz="1400" b="1" i="0">
+                        <a:rPr sz="1500" b="1" i="0">
                           <a:solidFill>
                             <a:srgbClr val="FFFFFF"/>
                           </a:solidFill>
@@ -8779,9 +8783,13 @@
                     <a:bodyPr wrap="square"/>
                     <a:lstStyle/>
                     <a:p>
-                      <a:pPr algn="l"/>
+                      <a:pPr algn="l">
+                        <a:spcAft>
+                          <a:spcPts val="600"/>
+                        </a:spcAft>
+                      </a:pPr>
                       <a:r>
-                        <a:rPr sz="1400" b="1" i="0">
+                        <a:rPr sz="1500" b="1" i="0">
                           <a:solidFill>
                             <a:srgbClr val="FFFFFF"/>
                           </a:solidFill>
@@ -8804,9 +8812,13 @@
                     <a:bodyPr wrap="square"/>
                     <a:lstStyle/>
                     <a:p>
-                      <a:pPr algn="l"/>
+                      <a:pPr algn="l">
+                        <a:spcAft>
+                          <a:spcPts val="600"/>
+                        </a:spcAft>
+                      </a:pPr>
                       <a:r>
-                        <a:rPr sz="1400" b="1" i="0">
+                        <a:rPr sz="1500" b="1" i="0">
                           <a:solidFill>
                             <a:srgbClr val="FFFFFF"/>
                           </a:solidFill>
@@ -8829,9 +8841,13 @@
                     <a:bodyPr wrap="square"/>
                     <a:lstStyle/>
                     <a:p>
-                      <a:pPr algn="l"/>
+                      <a:pPr algn="l">
+                        <a:spcAft>
+                          <a:spcPts val="600"/>
+                        </a:spcAft>
+                      </a:pPr>
                       <a:r>
-                        <a:rPr sz="1400" b="1" i="0">
+                        <a:rPr sz="1500" b="1" i="0">
                           <a:solidFill>
                             <a:srgbClr val="FFFFFF"/>
                           </a:solidFill>
@@ -8850,15 +8866,19 @@
                   </a:tcPr>
                 </a:tc>
               </a:tr>
-              <a:tr h="1035000">
+              <a:tr h="4000000">
                 <a:tc>
                   <a:txBody>
                     <a:bodyPr wrap="square"/>
                     <a:lstStyle/>
                     <a:p>
-                      <a:pPr algn="l"/>
+                      <a:pPr algn="l">
+                        <a:spcAft>
+                          <a:spcPts val="600"/>
+                        </a:spcAft>
+                      </a:pPr>
                       <a:r>
-                        <a:rPr sz="1300" b="0" i="0">
+                        <a:rPr sz="1400" b="0" i="0">
                           <a:solidFill>
                             <a:srgbClr val="1A2332"/>
                           </a:solidFill>
@@ -8866,11 +8886,65 @@
                           <a:ea typeface="Calibri"/>
                           <a:cs typeface="Calibri"/>
                         </a:rPr>
-                        <a:t>5–15 минут в смену, с телефона или компьютера — без отрыва на целый день</a:t>
+                        <a:t>•  Не отрывается от работы</a:t>
+                      </a:r>
+                    </a:p>
+                    <a:p>
+                      <a:pPr algn="l">
+                        <a:spcAft>
+                          <a:spcPts val="600"/>
+                        </a:spcAft>
+                      </a:pPr>
+                      <a:r>
+                        <a:rPr sz="1400" b="0" i="0">
+                          <a:solidFill>
+                            <a:srgbClr val="1A2332"/>
+                          </a:solidFill>
+                          <a:latin typeface="Calibri"/>
+                          <a:ea typeface="Calibri"/>
+                          <a:cs typeface="Calibri"/>
+                        </a:rPr>
+                        <a:t>•  Учится в течение смены</a:t>
+                      </a:r>
+                    </a:p>
+                    <a:p>
+                      <a:pPr algn="l">
+                        <a:spcAft>
+                          <a:spcPts val="600"/>
+                        </a:spcAft>
+                      </a:pPr>
+                      <a:r>
+                        <a:rPr sz="1400" b="0" i="0">
+                          <a:solidFill>
+                            <a:srgbClr val="1A2332"/>
+                          </a:solidFill>
+                          <a:latin typeface="Calibri"/>
+                          <a:ea typeface="Calibri"/>
+                          <a:cs typeface="Calibri"/>
+                        </a:rPr>
+                        <a:t>•  Регулярно закрепляет навык</a:t>
+                      </a:r>
+                    </a:p>
+                    <a:p>
+                      <a:pPr algn="l">
+                        <a:spcAft>
+                          <a:spcPts val="600"/>
+                        </a:spcAft>
+                      </a:pPr>
+                      <a:r>
+                        <a:rPr sz="1400" b="0" i="0">
+                          <a:solidFill>
+                            <a:srgbClr val="1A2332"/>
+                          </a:solidFill>
+                          <a:latin typeface="Calibri"/>
+                          <a:ea typeface="Calibri"/>
+                          <a:cs typeface="Calibri"/>
+                        </a:rPr>
+                        <a:t>•  Постоянно вовлечён</a:t>
                       </a:r>
                     </a:p>
                   </a:txBody>
-                  <a:tcPr anchor="ctr">
+                  <a:tcPr anchor="t">
                     <a:solidFill>
                       <a:srgbClr val="FFFFFF"/>
                     </a:solidFill>
@@ -8881,9 +8955,13 @@
                     <a:bodyPr wrap="square"/>
                     <a:lstStyle/>
                     <a:p>
-                      <a:pPr algn="l"/>
+                      <a:pPr algn="l">
+                        <a:spcAft>
+                          <a:spcPts val="600"/>
+                        </a:spcAft>
+                      </a:pPr>
                       <a:r>
-                        <a:rPr sz="1300" b="0" i="0">
+                        <a:rPr sz="1400" b="0" i="0">
                           <a:solidFill>
                             <a:srgbClr val="1A2332"/>
                           </a:solidFill>
@@ -8891,11 +8969,47 @@
                           <a:ea typeface="Calibri"/>
                           <a:cs typeface="Calibri"/>
                         </a:rPr>
-                        <a:t>Назначения группам и должностям без ручного Excel</a:t>
+                        <a:t>•  Назначения по категории работника</a:t>
+                      </a:r>
+                    </a:p>
+                    <a:p>
+                      <a:pPr algn="l">
+                        <a:spcAft>
+                          <a:spcPts val="600"/>
+                        </a:spcAft>
+                      </a:pPr>
+                      <a:r>
+                        <a:rPr sz="1400" b="0" i="0">
+                          <a:solidFill>
+                            <a:srgbClr val="1A2332"/>
+                          </a:solidFill>
+                          <a:latin typeface="Calibri"/>
+                          <a:ea typeface="Calibri"/>
+                          <a:cs typeface="Calibri"/>
+                        </a:rPr>
+                        <a:t>•  Простое управление программами</a:t>
+                      </a:r>
+                    </a:p>
+                    <a:p>
+                      <a:pPr algn="l">
+                        <a:spcAft>
+                          <a:spcPts val="600"/>
+                        </a:spcAft>
+                      </a:pPr>
+                      <a:r>
+                        <a:rPr sz="1400" b="0" i="0">
+                          <a:solidFill>
+                            <a:srgbClr val="1A2332"/>
+                          </a:solidFill>
+                          <a:latin typeface="Calibri"/>
+                          <a:ea typeface="Calibri"/>
+                          <a:cs typeface="Calibri"/>
+                        </a:rPr>
+                        <a:t>•  Аналитика, чтобы координировать обучающихся</a:t>
                       </a:r>
                     </a:p>
                   </a:txBody>
-                  <a:tcPr anchor="ctr">
+                  <a:tcPr anchor="t">
                     <a:solidFill>
                       <a:srgbClr val="FFFFFF"/>
                     </a:solidFill>
@@ -8906,9 +9020,13 @@
                     <a:bodyPr wrap="square"/>
                     <a:lstStyle/>
                     <a:p>
-                      <a:pPr algn="l"/>
+                      <a:pPr algn="l">
+                        <a:spcAft>
+                          <a:spcPts val="600"/>
+                        </a:spcAft>
+                      </a:pPr>
                       <a:r>
-                        <a:rPr sz="1300" b="0" i="0">
+                        <a:rPr sz="1400" b="0" i="0">
                           <a:solidFill>
                             <a:srgbClr val="1A2332"/>
                           </a:solidFill>
@@ -8916,11 +9034,65 @@
                           <a:ea typeface="Calibri"/>
                           <a:cs typeface="Calibri"/>
                         </a:rPr>
-                        <a:t>Поддерживающий контур между проверками знаний раз в 3 года</a:t>
+                        <a:t>•  Снижение инцидентов</a:t>
+                      </a:r>
+                    </a:p>
+                    <a:p>
+                      <a:pPr algn="l">
+                        <a:spcAft>
+                          <a:spcPts val="600"/>
+                        </a:spcAft>
+                      </a:pPr>
+                      <a:r>
+                        <a:rPr sz="1400" b="0" i="0">
+                          <a:solidFill>
+                            <a:srgbClr val="1A2332"/>
+                          </a:solidFill>
+                          <a:latin typeface="Calibri"/>
+                          <a:ea typeface="Calibri"/>
+                          <a:cs typeface="Calibri"/>
+                        </a:rPr>
+                        <a:t>•  Программы завязаны на реальные зоны риска</a:t>
+                      </a:r>
+                    </a:p>
+                    <a:p>
+                      <a:pPr algn="l">
+                        <a:spcAft>
+                          <a:spcPts val="600"/>
+                        </a:spcAft>
+                      </a:pPr>
+                      <a:r>
+                        <a:rPr sz="1400" b="0" i="0">
+                          <a:solidFill>
+                            <a:srgbClr val="1A2332"/>
+                          </a:solidFill>
+                          <a:latin typeface="Calibri"/>
+                          <a:ea typeface="Calibri"/>
+                          <a:cs typeface="Calibri"/>
+                        </a:rPr>
+                        <a:t>•  Акцент на нарушениях и происшествиях</a:t>
+                      </a:r>
+                    </a:p>
+                    <a:p>
+                      <a:pPr algn="l">
+                        <a:spcAft>
+                          <a:spcPts val="600"/>
+                        </a:spcAft>
+                      </a:pPr>
+                      <a:r>
+                        <a:rPr sz="1400" b="0" i="0">
+                          <a:solidFill>
+                            <a:srgbClr val="1A2332"/>
+                          </a:solidFill>
+                          <a:latin typeface="Calibri"/>
+                          <a:ea typeface="Calibri"/>
+                          <a:cs typeface="Calibri"/>
+                        </a:rPr>
+                        <a:t>•  Культура безопасности: регулярный диалог с работниками через систему</a:t>
                       </a:r>
                     </a:p>
                   </a:txBody>
-                  <a:tcPr anchor="ctr">
+                  <a:tcPr anchor="t">
                     <a:solidFill>
                       <a:srgbClr val="FFFFFF"/>
                     </a:solidFill>
@@ -8931,9 +9103,13 @@
                     <a:bodyPr wrap="square"/>
                     <a:lstStyle/>
                     <a:p>
-                      <a:pPr algn="l"/>
+                      <a:pPr algn="l">
+                        <a:spcAft>
+                          <a:spcPts val="600"/>
+                        </a:spcAft>
+                      </a:pPr>
                       <a:r>
-                        <a:rPr sz="1300" b="0" i="0">
+                        <a:rPr sz="1400" b="0" i="0">
                           <a:solidFill>
                             <a:srgbClr val="1A2332"/>
                           </a:solidFill>
@@ -8941,26 +9117,17 @@
                           <a:ea typeface="Calibri"/>
                           <a:cs typeface="Calibri"/>
                         </a:rPr>
-                        <a:t>Меньше «обучения для галочки» и потерянных человеко-часов</a:t>
+                        <a:t>•  Меньше расходов на тренинги, которые не снижают травматизм</a:t>
                       </a:r>
                     </a:p>
-                  </a:txBody>
-                  <a:tcPr anchor="ctr">
-                    <a:solidFill>
-                      <a:srgbClr val="FFFFFF"/>
-                    </a:solidFill>
-                  </a:tcPr>
-                </a:tc>
-              </a:tr>
-              <a:tr h="1035000">
-                <a:tc>
-                  <a:txBody>
-                    <a:bodyPr wrap="square"/>
-                    <a:lstStyle/>
                     <a:p>
-                      <a:pPr algn="l"/>
+                      <a:pPr algn="l">
+                        <a:spcAft>
+                          <a:spcPts val="600"/>
+                        </a:spcAft>
+                      </a:pPr>
                       <a:r>
-                        <a:rPr sz="1300" b="0" i="0">
+                        <a:rPr sz="1400" b="0" i="0">
                           <a:solidFill>
                             <a:srgbClr val="1A2332"/>
                           </a:solidFill>
@@ -8968,24 +9135,17 @@
                           <a:ea typeface="Calibri"/>
                           <a:cs typeface="Calibri"/>
                         </a:rPr>
-                        <a:t>Понятный трек: что пройти сегодня и что откроется дальше</a:t>
+                        <a:t>•  Меньше времени сотрудников на обучение без результата</a:t>
                       </a:r>
                     </a:p>
-                  </a:txBody>
-                  <a:tcPr anchor="ctr">
-                    <a:solidFill>
-                      <a:srgbClr val="F5F7FA"/>
-                    </a:solidFill>
-                  </a:tcPr>
-                </a:tc>
-                <a:tc>
-                  <a:txBody>
-                    <a:bodyPr wrap="square"/>
-                    <a:lstStyle/>
                     <a:p>
-                      <a:pPr algn="l"/>
+                      <a:pPr algn="l">
+                        <a:spcAft>
+                          <a:spcPts val="600"/>
+                        </a:spcAft>
+                      </a:pPr>
                       <a:r>
-                        <a:rPr sz="1300" b="0" i="0">
+                        <a:rPr sz="1400" b="0" i="0">
                           <a:solidFill>
                             <a:srgbClr val="1A2332"/>
                           </a:solidFill>
@@ -8993,267 +9153,13 @@
                           <a:ea typeface="Calibri"/>
                           <a:cs typeface="Calibri"/>
                         </a:rPr>
-                        <a:t>Сразу видно, кто не прошёл, кто просрочил, кому напомнить</a:t>
+                        <a:t>•  Реальный эффект: меньше нарушений и несчастных случаев</a:t>
                       </a:r>
                     </a:p>
                   </a:txBody>
-                  <a:tcPr anchor="ctr">
-                    <a:solidFill>
-                      <a:srgbClr val="F5F7FA"/>
-                    </a:solidFill>
-                  </a:tcPr>
-                </a:tc>
-                <a:tc>
-                  <a:txBody>
-                    <a:bodyPr wrap="square"/>
-                    <a:lstStyle/>
-                    <a:p>
-                      <a:pPr algn="l"/>
-                      <a:r>
-                        <a:rPr sz="1300" b="0" i="0">
-                          <a:solidFill>
-                            <a:srgbClr val="1A2332"/>
-                          </a:solidFill>
-                          <a:latin typeface="Calibri"/>
-                          <a:ea typeface="Calibri"/>
-                          <a:cs typeface="Calibri"/>
-                        </a:rPr>
-                        <a:t>Слабые темы и просрочки по подразделениям — не скопом по всей компании</a:t>
-                      </a:r>
-                    </a:p>
-                  </a:txBody>
-                  <a:tcPr anchor="ctr">
-                    <a:solidFill>
-                      <a:srgbClr val="F5F7FA"/>
-                    </a:solidFill>
-                  </a:tcPr>
-                </a:tc>
-                <a:tc>
-                  <a:txBody>
-                    <a:bodyPr wrap="square"/>
-                    <a:lstStyle/>
-                    <a:p>
-                      <a:pPr algn="l"/>
-                      <a:r>
-                        <a:rPr sz="1300" b="0" i="0">
-                          <a:solidFill>
-                            <a:srgbClr val="1A2332"/>
-                          </a:solidFill>
-                          <a:latin typeface="Calibri"/>
-                          <a:ea typeface="Calibri"/>
-                          <a:cs typeface="Calibri"/>
-                        </a:rPr>
-                        <a:t>Единая картина по филиалам: вовлечённость, просрочки, прогресс</a:t>
-                      </a:r>
-                    </a:p>
-                  </a:txBody>
-                  <a:tcPr anchor="ctr">
-                    <a:solidFill>
-                      <a:srgbClr val="F5F7FA"/>
-                    </a:solidFill>
-                  </a:tcPr>
-                </a:tc>
-              </a:tr>
-              <a:tr h="1035000">
-                <a:tc>
-                  <a:txBody>
-                    <a:bodyPr wrap="square"/>
-                    <a:lstStyle/>
-                    <a:p>
-                      <a:pPr algn="l"/>
-                      <a:r>
-                        <a:rPr sz="1300" b="0" i="0">
-                          <a:solidFill>
-                            <a:srgbClr val="1A2332"/>
-                          </a:solidFill>
-                          <a:latin typeface="Calibri"/>
-                          <a:ea typeface="Calibri"/>
-                          <a:cs typeface="Calibri"/>
-                        </a:rPr>
-                        <a:t>Баллы и рейтинг вместо формальной галочки раз в несколько лет</a:t>
-                      </a:r>
-                    </a:p>
-                  </a:txBody>
-                  <a:tcPr anchor="ctr">
+                  <a:tcPr anchor="t">
                     <a:solidFill>
                       <a:srgbClr val="FFFFFF"/>
-                    </a:solidFill>
-                  </a:tcPr>
-                </a:tc>
-                <a:tc>
-                  <a:txBody>
-                    <a:bodyPr wrap="square"/>
-                    <a:lstStyle/>
-                    <a:p>
-                      <a:pPr algn="l"/>
-                      <a:r>
-                        <a:rPr sz="1300" b="0" i="0">
-                          <a:solidFill>
-                            <a:srgbClr val="1A2332"/>
-                          </a:solidFill>
-                          <a:latin typeface="Calibri"/>
-                          <a:ea typeface="Calibri"/>
-                          <a:cs typeface="Calibri"/>
-                        </a:rPr>
-                        <a:t>Ежедневный ритм снижает ручной контроль и «догонялки» к проверке</a:t>
-                      </a:r>
-                    </a:p>
-                  </a:txBody>
-                  <a:tcPr anchor="ctr">
-                    <a:solidFill>
-                      <a:srgbClr val="FFFFFF"/>
-                    </a:solidFill>
-                  </a:tcPr>
-                </a:tc>
-                <a:tc>
-                  <a:txBody>
-                    <a:bodyPr wrap="square"/>
-                    <a:lstStyle/>
-                    <a:p>
-                      <a:pPr algn="l"/>
-                      <a:r>
-                        <a:rPr sz="1300" b="0" i="0">
-                          <a:solidFill>
-                            <a:srgbClr val="1A2332"/>
-                          </a:solidFill>
-                          <a:latin typeface="Calibri"/>
-                          <a:ea typeface="Calibri"/>
-                          <a:cs typeface="Calibri"/>
-                        </a:rPr>
-                        <a:t>Нормативка в микрокурсах и выгрузка отчёта к проверке</a:t>
-                      </a:r>
-                    </a:p>
-                  </a:txBody>
-                  <a:tcPr anchor="ctr">
-                    <a:solidFill>
-                      <a:srgbClr val="FFFFFF"/>
-                    </a:solidFill>
-                  </a:tcPr>
-                </a:tc>
-                <a:tc>
-                  <a:txBody>
-                    <a:bodyPr wrap="square"/>
-                    <a:lstStyle/>
-                    <a:p>
-                      <a:pPr algn="l"/>
-                      <a:r>
-                        <a:rPr sz="1300" b="0" i="0">
-                          <a:solidFill>
-                            <a:srgbClr val="1A2332"/>
-                          </a:solidFill>
-                          <a:latin typeface="Calibri"/>
-                          <a:ea typeface="Calibri"/>
-                          <a:cs typeface="Calibri"/>
-                        </a:rPr>
-                        <a:t>Вовлечённость как ведущий индикатор риска — до травмы и штрафа</a:t>
-                      </a:r>
-                    </a:p>
-                  </a:txBody>
-                  <a:tcPr anchor="ctr">
-                    <a:solidFill>
-                      <a:srgbClr val="FFFFFF"/>
-                    </a:solidFill>
-                  </a:tcPr>
-                </a:tc>
-              </a:tr>
-              <a:tr h="1035000">
-                <a:tc>
-                  <a:txBody>
-                    <a:bodyPr wrap="square"/>
-                    <a:lstStyle/>
-                    <a:p>
-                      <a:pPr algn="l"/>
-                      <a:r>
-                        <a:rPr sz="1300" b="0" i="0">
-                          <a:solidFill>
-                            <a:srgbClr val="1A2332"/>
-                          </a:solidFill>
-                          <a:latin typeface="Calibri"/>
-                          <a:ea typeface="Calibri"/>
-                          <a:cs typeface="Calibri"/>
-                        </a:rPr>
-                        <a:t>Знания удерживаются в работе, а не выветриваются после курса</a:t>
-                      </a:r>
-                    </a:p>
-                  </a:txBody>
-                  <a:tcPr anchor="ctr">
-                    <a:solidFill>
-                      <a:srgbClr val="F5F7FA"/>
-                    </a:solidFill>
-                  </a:tcPr>
-                </a:tc>
-                <a:tc>
-                  <a:txBody>
-                    <a:bodyPr wrap="square"/>
-                    <a:lstStyle/>
-                    <a:p>
-                      <a:pPr algn="l"/>
-                      <a:r>
-                        <a:rPr sz="1300" b="0" i="0">
-                          <a:solidFill>
-                            <a:srgbClr val="1A2332"/>
-                          </a:solidFill>
-                          <a:latin typeface="Calibri"/>
-                          <a:ea typeface="Calibri"/>
-                          <a:cs typeface="Calibri"/>
-                        </a:rPr>
-                        <a:t>Отчёт по группе к разбору с руководителем смены</a:t>
-                      </a:r>
-                    </a:p>
-                  </a:txBody>
-                  <a:tcPr anchor="ctr">
-                    <a:solidFill>
-                      <a:srgbClr val="F5F7FA"/>
-                    </a:solidFill>
-                  </a:tcPr>
-                </a:tc>
-                <a:tc>
-                  <a:txBody>
-                    <a:bodyPr wrap="square"/>
-                    <a:lstStyle/>
-                    <a:p>
-                      <a:pPr algn="l"/>
-                      <a:r>
-                        <a:rPr sz="1300" b="0" i="0">
-                          <a:solidFill>
-                            <a:srgbClr val="1A2332"/>
-                          </a:solidFill>
-                          <a:latin typeface="Calibri"/>
-                          <a:ea typeface="Calibri"/>
-                          <a:cs typeface="Calibri"/>
-                        </a:rPr>
-                        <a:t>Можно точечно усилить программу после инцидента или предписания</a:t>
-                      </a:r>
-                    </a:p>
-                  </a:txBody>
-                  <a:tcPr anchor="ctr">
-                    <a:solidFill>
-                      <a:srgbClr val="F5F7FA"/>
-                    </a:solidFill>
-                  </a:tcPr>
-                </a:tc>
-                <a:tc>
-                  <a:txBody>
-                    <a:bodyPr wrap="square"/>
-                    <a:lstStyle/>
-                    <a:p>
-                      <a:pPr algn="l"/>
-                      <a:r>
-                        <a:rPr sz="1300" b="0" i="0">
-                          <a:solidFill>
-                            <a:srgbClr val="1A2332"/>
-                          </a:solidFill>
-                          <a:latin typeface="Calibri"/>
-                          <a:ea typeface="Calibri"/>
-                          <a:cs typeface="Calibri"/>
-                        </a:rPr>
-                        <a:t>Ниже вероятность НС, простоя и повторных затрат на формальное обучение</a:t>
-                      </a:r>
-                    </a:p>
-                  </a:txBody>
-                  <a:tcPr anchor="ctr">
-                    <a:solidFill>
-                      <a:srgbClr val="F5F7FA"/>
                     </a:solidFill>
                   </a:tcPr>
                 </a:tc>

</xml_diff>

<commit_message>
Add a three-panel slide: LMS, classroom, and microlearning.
Captions on top of each block; scenes show disengagement vs active thinking.

Co-authored-by: lysakalenushka-hash <lysakalenushka-hash@users.noreply.github.com>
</commit_message>
<xml_diff>
--- a/issledovaniya/Lab-Intellekt_prodayushchaya-prezentaciya_v2.pptx
+++ b/issledovaniya/Lab-Intellekt_prodayushchaya-prezentaciya_v2.pptx
@@ -23,6 +23,7 @@
     <p:sldId id="269" r:id="rId14"/>
     <p:sldId id="272" r:id="rId15"/>
     <p:sldId id="273" r:id="rId16"/>
+    <p:sldId id="274" r:id="rId22"/>
   </p:sldIdLst>
   <p:sldSz cx="12192000" cy="6858000"/>
   <p:notesSz cx="6858000" cy="9144000"/>
@@ -9176,6 +9177,825 @@
 </p:sld>
 </file>
 
+<file path=ppt/slides/slide16.xml><?xml version="1.0" encoding="utf-8"?>
+<p:sld xmlns:a="http://schemas.openxmlformats.org/drawingml/2006/main" xmlns:p="http://schemas.openxmlformats.org/presentationml/2006/main" xmlns:r="http://schemas.openxmlformats.org/officeDocument/2006/relationships">
+  <p:cSld>
+    <p:spTree>
+      <p:nvGrpSpPr>
+        <p:cNvPr id="1" name=""/>
+        <p:cNvGrpSpPr/>
+        <p:nvPr/>
+      </p:nvGrpSpPr>
+      <p:grpSpPr/>
+      <p:sp>
+        <p:nvSpPr>
+          <p:cNvPr id="2" name="Rectangle 1"/>
+          <p:cNvSpPr/>
+          <p:nvPr/>
+        </p:nvSpPr>
+        <p:spPr>
+          <a:xfrm>
+            <a:off x="0" y="0"/>
+            <a:ext cx="12192000" cy="6858000"/>
+          </a:xfrm>
+          <a:prstGeom prst="rect">
+            <a:avLst/>
+          </a:prstGeom>
+          <a:solidFill>
+            <a:srgbClr val="F5F7FA"/>
+          </a:solidFill>
+          <a:ln>
+            <a:noFill/>
+          </a:ln>
+          <a:effectLst/>
+        </p:spPr>
+        <p:style>
+          <a:lnRef idx="1">
+            <a:schemeClr val="accent1"/>
+          </a:lnRef>
+          <a:fillRef idx="3">
+            <a:schemeClr val="accent1"/>
+          </a:fillRef>
+          <a:effectRef idx="2">
+            <a:schemeClr val="accent1"/>
+          </a:effectRef>
+          <a:fontRef idx="minor">
+            <a:schemeClr val="lt1"/>
+          </a:fontRef>
+        </p:style>
+        <p:txBody>
+          <a:bodyPr rtlCol="0" anchor="ctr"/>
+          <a:lstStyle/>
+          <a:p>
+            <a:pPr algn="ctr"/>
+          </a:p>
+        </p:txBody>
+      </p:sp>
+      <p:sp>
+        <p:nvSpPr>
+          <p:cNvPr id="3" name="Rectangle 2"/>
+          <p:cNvSpPr/>
+          <p:nvPr/>
+        </p:nvSpPr>
+        <p:spPr>
+          <a:xfrm>
+            <a:off x="0" y="0"/>
+            <a:ext cx="109728" cy="6858000"/>
+          </a:xfrm>
+          <a:prstGeom prst="rect">
+            <a:avLst/>
+          </a:prstGeom>
+          <a:solidFill>
+            <a:srgbClr val="1A9B8A"/>
+          </a:solidFill>
+          <a:ln>
+            <a:noFill/>
+          </a:ln>
+          <a:effectLst/>
+        </p:spPr>
+        <p:style>
+          <a:lnRef idx="1">
+            <a:schemeClr val="accent1"/>
+          </a:lnRef>
+          <a:fillRef idx="3">
+            <a:schemeClr val="accent1"/>
+          </a:fillRef>
+          <a:effectRef idx="2">
+            <a:schemeClr val="accent1"/>
+          </a:effectRef>
+          <a:fontRef idx="minor">
+            <a:schemeClr val="lt1"/>
+          </a:fontRef>
+        </p:style>
+        <p:txBody>
+          <a:bodyPr rtlCol="0" anchor="ctr"/>
+          <a:lstStyle/>
+          <a:p>
+            <a:pPr algn="ctr"/>
+          </a:p>
+        </p:txBody>
+      </p:sp>
+      <p:sp>
+        <p:nvSpPr>
+          <p:cNvPr id="4" name="Rectangle 3"/>
+          <p:cNvSpPr/>
+          <p:nvPr/>
+        </p:nvSpPr>
+        <p:spPr>
+          <a:xfrm>
+            <a:off x="0" y="0"/>
+            <a:ext cx="12192000" cy="73152"/>
+          </a:xfrm>
+          <a:prstGeom prst="rect">
+            <a:avLst/>
+          </a:prstGeom>
+          <a:solidFill>
+            <a:srgbClr val="1A9B8A"/>
+          </a:solidFill>
+          <a:ln>
+            <a:noFill/>
+          </a:ln>
+          <a:effectLst/>
+        </p:spPr>
+        <p:style>
+          <a:lnRef idx="1">
+            <a:schemeClr val="accent1"/>
+          </a:lnRef>
+          <a:fillRef idx="3">
+            <a:schemeClr val="accent1"/>
+          </a:fillRef>
+          <a:effectRef idx="2">
+            <a:schemeClr val="accent1"/>
+          </a:effectRef>
+          <a:fontRef idx="minor">
+            <a:schemeClr val="lt1"/>
+          </a:fontRef>
+        </p:style>
+        <p:txBody>
+          <a:bodyPr rtlCol="0" anchor="ctr"/>
+          <a:lstStyle/>
+          <a:p>
+            <a:pPr algn="ctr"/>
+          </a:p>
+        </p:txBody>
+      </p:sp>
+      <p:sp>
+        <p:nvSpPr>
+          <p:cNvPr id="5" name="TextBox 4"/>
+          <p:cNvSpPr txBox="1"/>
+          <p:nvPr/>
+        </p:nvSpPr>
+        <p:spPr>
+          <a:xfrm>
+            <a:off x="502920" y="160000"/>
+            <a:ext cx="11155680" cy="260000"/>
+          </a:xfrm>
+          <a:prstGeom prst="rect">
+            <a:avLst/>
+          </a:prstGeom>
+          <a:noFill/>
+        </p:spPr>
+        <p:txBody>
+          <a:bodyPr wrap="square" anchor="ctr">
+            <a:spAutoFit/>
+          </a:bodyPr>
+          <a:lstStyle/>
+          <a:p>
+            <a:pPr algn="l"/>
+            <a:r>
+              <a:rPr sz="1200" b="1" i="0">
+                <a:solidFill>
+                  <a:srgbClr val="1A9B8A"/>
+                </a:solidFill>
+                <a:latin typeface="Calibri"/>
+                <a:ea typeface="Calibri"/>
+                <a:cs typeface="Calibri"/>
+              </a:rPr>
+              <a:t>ТРИ ФОРМАТА</a:t>
+            </a:r>
+          </a:p>
+        </p:txBody>
+      </p:sp>
+      <p:sp>
+        <p:nvSpPr>
+          <p:cNvPr id="6" name="TextBox 5"/>
+          <p:cNvSpPr txBox="1"/>
+          <p:nvPr/>
+        </p:nvSpPr>
+        <p:spPr>
+          <a:xfrm>
+            <a:off x="502920" y="380000"/>
+            <a:ext cx="11155680" cy="420000"/>
+          </a:xfrm>
+          <a:prstGeom prst="rect">
+            <a:avLst/>
+          </a:prstGeom>
+          <a:noFill/>
+        </p:spPr>
+        <p:txBody>
+          <a:bodyPr wrap="square" anchor="ctr">
+            <a:spAutoFit/>
+          </a:bodyPr>
+          <a:lstStyle/>
+          <a:p>
+            <a:pPr algn="l"/>
+            <a:r>
+              <a:rPr sz="2600" b="1" i="0">
+                <a:solidFill>
+                  <a:srgbClr val="1A2332"/>
+                </a:solidFill>
+                <a:latin typeface="Calibri"/>
+                <a:ea typeface="Calibri"/>
+                <a:cs typeface="Calibri"/>
+              </a:rPr>
+              <a:t>Кто реально учится — видно сразу</a:t>
+            </a:r>
+          </a:p>
+        </p:txBody>
+      </p:sp>
+      <p:sp>
+        <p:nvSpPr>
+          <p:cNvPr id="7" name="Rounded Rectangle 6"/>
+          <p:cNvSpPr/>
+          <p:nvPr/>
+        </p:nvSpPr>
+        <p:spPr>
+          <a:xfrm>
+            <a:off x="420000" y="900000"/>
+            <a:ext cx="3650000" cy="5450000"/>
+          </a:xfrm>
+          <a:prstGeom prst="roundRect">
+            <a:avLst/>
+          </a:prstGeom>
+          <a:solidFill>
+            <a:srgbClr val="FFFFFF"/>
+          </a:solidFill>
+          <a:ln>
+            <a:noFill/>
+          </a:ln>
+          <a:effectLst/>
+        </p:spPr>
+        <p:style>
+          <a:lnRef idx="1">
+            <a:schemeClr val="accent1"/>
+          </a:lnRef>
+          <a:fillRef idx="3">
+            <a:schemeClr val="accent1"/>
+          </a:fillRef>
+          <a:effectRef idx="2">
+            <a:schemeClr val="accent1"/>
+          </a:effectRef>
+          <a:fontRef idx="minor">
+            <a:schemeClr val="lt1"/>
+          </a:fontRef>
+        </p:style>
+        <p:txBody>
+          <a:bodyPr rtlCol="0" anchor="ctr"/>
+          <a:lstStyle/>
+          <a:p>
+            <a:pPr algn="ctr"/>
+          </a:p>
+        </p:txBody>
+      </p:sp>
+      <p:sp>
+        <p:nvSpPr>
+          <p:cNvPr id="8" name="Rectangle 7"/>
+          <p:cNvSpPr/>
+          <p:nvPr/>
+        </p:nvSpPr>
+        <p:spPr>
+          <a:xfrm>
+            <a:off x="420000" y="900000"/>
+            <a:ext cx="3650000" cy="780000"/>
+          </a:xfrm>
+          <a:prstGeom prst="rect">
+            <a:avLst/>
+          </a:prstGeom>
+          <a:solidFill>
+            <a:srgbClr val="0B1F3A"/>
+          </a:solidFill>
+          <a:ln>
+            <a:noFill/>
+          </a:ln>
+          <a:effectLst/>
+        </p:spPr>
+        <p:style>
+          <a:lnRef idx="1">
+            <a:schemeClr val="accent1"/>
+          </a:lnRef>
+          <a:fillRef idx="3">
+            <a:schemeClr val="accent1"/>
+          </a:fillRef>
+          <a:effectRef idx="2">
+            <a:schemeClr val="accent1"/>
+          </a:effectRef>
+          <a:fontRef idx="minor">
+            <a:schemeClr val="lt1"/>
+          </a:fontRef>
+        </p:style>
+        <p:txBody>
+          <a:bodyPr rtlCol="0" anchor="ctr"/>
+          <a:lstStyle/>
+          <a:p>
+            <a:pPr algn="ctr"/>
+          </a:p>
+        </p:txBody>
+      </p:sp>
+      <p:sp>
+        <p:nvSpPr>
+          <p:cNvPr id="9" name="TextBox 8"/>
+          <p:cNvSpPr txBox="1"/>
+          <p:nvPr/>
+        </p:nvSpPr>
+        <p:spPr>
+          <a:xfrm>
+            <a:off x="500000" y="990000"/>
+            <a:ext cx="3490000" cy="380000"/>
+          </a:xfrm>
+          <a:prstGeom prst="rect">
+            <a:avLst/>
+          </a:prstGeom>
+          <a:noFill/>
+        </p:spPr>
+        <p:txBody>
+          <a:bodyPr wrap="square" anchor="ctr">
+            <a:spAutoFit/>
+          </a:bodyPr>
+          <a:lstStyle/>
+          <a:p>
+            <a:pPr algn="ctr"/>
+            <a:r>
+              <a:rPr sz="2000" b="1" i="0">
+                <a:solidFill>
+                  <a:srgbClr val="FFFFFF"/>
+                </a:solidFill>
+                <a:latin typeface="Calibri"/>
+                <a:ea typeface="Calibri"/>
+                <a:cs typeface="Calibri"/>
+              </a:rPr>
+              <a:t>СДО</a:t>
+            </a:r>
+          </a:p>
+        </p:txBody>
+      </p:sp>
+      <p:sp>
+        <p:nvSpPr>
+          <p:cNvPr id="10" name="TextBox 9"/>
+          <p:cNvSpPr txBox="1"/>
+          <p:nvPr/>
+        </p:nvSpPr>
+        <p:spPr>
+          <a:xfrm>
+            <a:off x="500000" y="1330000"/>
+            <a:ext cx="3490000" cy="280000"/>
+          </a:xfrm>
+          <a:prstGeom prst="rect">
+            <a:avLst/>
+          </a:prstGeom>
+          <a:noFill/>
+        </p:spPr>
+        <p:txBody>
+          <a:bodyPr wrap="square" anchor="ctr">
+            <a:spAutoFit/>
+          </a:bodyPr>
+          <a:lstStyle/>
+          <a:p>
+            <a:pPr algn="ctr"/>
+            <a:r>
+              <a:rPr sz="1200" b="0" i="0">
+                <a:solidFill>
+                  <a:srgbClr val="B8C5D6"/>
+                </a:solidFill>
+                <a:latin typeface="Calibri"/>
+                <a:ea typeface="Calibri"/>
+                <a:cs typeface="Calibri"/>
+              </a:rPr>
+              <a:t>Система дистанционного обучения</a:t>
+            </a:r>
+          </a:p>
+        </p:txBody>
+      </p:sp>
+      <p:pic>
+        <p:nvPicPr>
+          <p:cNvPr id="11" name="Picture 10" descr="blok-sdo.png"/>
+          <p:cNvPicPr>
+            <a:picLocks noChangeAspect="1"/>
+          </p:cNvPicPr>
+          <p:nvPr/>
+        </p:nvPicPr>
+        <p:blipFill>
+          <a:blip r:embed="rId2"/>
+          <a:stretch>
+            <a:fillRect/>
+          </a:stretch>
+        </p:blipFill>
+        <p:spPr>
+          <a:xfrm>
+            <a:off x="460000" y="1720000"/>
+            <a:ext cx="3570000" cy="4590000"/>
+          </a:xfrm>
+          <a:prstGeom prst="rect">
+            <a:avLst/>
+          </a:prstGeom>
+        </p:spPr>
+      </p:pic>
+      <p:sp>
+        <p:nvSpPr>
+          <p:cNvPr id="12" name="Rounded Rectangle 11"/>
+          <p:cNvSpPr/>
+          <p:nvPr/>
+        </p:nvSpPr>
+        <p:spPr>
+          <a:xfrm>
+            <a:off x="4230000" y="900000"/>
+            <a:ext cx="3650000" cy="5450000"/>
+          </a:xfrm>
+          <a:prstGeom prst="roundRect">
+            <a:avLst/>
+          </a:prstGeom>
+          <a:solidFill>
+            <a:srgbClr val="FFFFFF"/>
+          </a:solidFill>
+          <a:ln>
+            <a:noFill/>
+          </a:ln>
+          <a:effectLst/>
+        </p:spPr>
+        <p:style>
+          <a:lnRef idx="1">
+            <a:schemeClr val="accent1"/>
+          </a:lnRef>
+          <a:fillRef idx="3">
+            <a:schemeClr val="accent1"/>
+          </a:fillRef>
+          <a:effectRef idx="2">
+            <a:schemeClr val="accent1"/>
+          </a:effectRef>
+          <a:fontRef idx="minor">
+            <a:schemeClr val="lt1"/>
+          </a:fontRef>
+        </p:style>
+        <p:txBody>
+          <a:bodyPr rtlCol="0" anchor="ctr"/>
+          <a:lstStyle/>
+          <a:p>
+            <a:pPr algn="ctr"/>
+          </a:p>
+        </p:txBody>
+      </p:sp>
+      <p:sp>
+        <p:nvSpPr>
+          <p:cNvPr id="13" name="Rectangle 12"/>
+          <p:cNvSpPr/>
+          <p:nvPr/>
+        </p:nvSpPr>
+        <p:spPr>
+          <a:xfrm>
+            <a:off x="4230000" y="900000"/>
+            <a:ext cx="3650000" cy="780000"/>
+          </a:xfrm>
+          <a:prstGeom prst="rect">
+            <a:avLst/>
+          </a:prstGeom>
+          <a:solidFill>
+            <a:srgbClr val="0B1F3A"/>
+          </a:solidFill>
+          <a:ln>
+            <a:noFill/>
+          </a:ln>
+          <a:effectLst/>
+        </p:spPr>
+        <p:style>
+          <a:lnRef idx="1">
+            <a:schemeClr val="accent1"/>
+          </a:lnRef>
+          <a:fillRef idx="3">
+            <a:schemeClr val="accent1"/>
+          </a:fillRef>
+          <a:effectRef idx="2">
+            <a:schemeClr val="accent1"/>
+          </a:effectRef>
+          <a:fontRef idx="minor">
+            <a:schemeClr val="lt1"/>
+          </a:fontRef>
+        </p:style>
+        <p:txBody>
+          <a:bodyPr rtlCol="0" anchor="ctr"/>
+          <a:lstStyle/>
+          <a:p>
+            <a:pPr algn="ctr"/>
+          </a:p>
+        </p:txBody>
+      </p:sp>
+      <p:sp>
+        <p:nvSpPr>
+          <p:cNvPr id="14" name="TextBox 13"/>
+          <p:cNvSpPr txBox="1"/>
+          <p:nvPr/>
+        </p:nvSpPr>
+        <p:spPr>
+          <a:xfrm>
+            <a:off x="4310000" y="990000"/>
+            <a:ext cx="3490000" cy="380000"/>
+          </a:xfrm>
+          <a:prstGeom prst="rect">
+            <a:avLst/>
+          </a:prstGeom>
+          <a:noFill/>
+        </p:spPr>
+        <p:txBody>
+          <a:bodyPr wrap="square" anchor="ctr">
+            <a:spAutoFit/>
+          </a:bodyPr>
+          <a:lstStyle/>
+          <a:p>
+            <a:pPr algn="ctr"/>
+            <a:r>
+              <a:rPr sz="2000" b="1" i="0">
+                <a:solidFill>
+                  <a:srgbClr val="FFFFFF"/>
+                </a:solidFill>
+                <a:latin typeface="Calibri"/>
+                <a:ea typeface="Calibri"/>
+                <a:cs typeface="Calibri"/>
+              </a:rPr>
+              <a:t>Очное обучение</a:t>
+            </a:r>
+          </a:p>
+        </p:txBody>
+      </p:sp>
+      <p:sp>
+        <p:nvSpPr>
+          <p:cNvPr id="15" name="TextBox 14"/>
+          <p:cNvSpPr txBox="1"/>
+          <p:nvPr/>
+        </p:nvSpPr>
+        <p:spPr>
+          <a:xfrm>
+            <a:off x="4310000" y="1330000"/>
+            <a:ext cx="3490000" cy="280000"/>
+          </a:xfrm>
+          <a:prstGeom prst="rect">
+            <a:avLst/>
+          </a:prstGeom>
+          <a:noFill/>
+        </p:spPr>
+        <p:txBody>
+          <a:bodyPr wrap="square" anchor="ctr">
+            <a:spAutoFit/>
+          </a:bodyPr>
+          <a:lstStyle/>
+          <a:p>
+            <a:pPr algn="ctr"/>
+            <a:r>
+              <a:rPr sz="1200" b="0" i="0">
+                <a:solidFill>
+                  <a:srgbClr val="B8C5D6"/>
+                </a:solidFill>
+                <a:latin typeface="Calibri"/>
+                <a:ea typeface="Calibri"/>
+                <a:cs typeface="Calibri"/>
+              </a:rPr>
+              <a:t>Класс и преподаватель</a:t>
+            </a:r>
+          </a:p>
+        </p:txBody>
+      </p:sp>
+      <p:pic>
+        <p:nvPicPr>
+          <p:cNvPr id="16" name="Picture 15" descr="blok-ochnoe.png"/>
+          <p:cNvPicPr>
+            <a:picLocks noChangeAspect="1"/>
+          </p:cNvPicPr>
+          <p:nvPr/>
+        </p:nvPicPr>
+        <p:blipFill>
+          <a:blip r:embed="rId3"/>
+          <a:stretch>
+            <a:fillRect/>
+          </a:stretch>
+        </p:blipFill>
+        <p:spPr>
+          <a:xfrm>
+            <a:off x="4270000" y="1720000"/>
+            <a:ext cx="3570000" cy="4590000"/>
+          </a:xfrm>
+          <a:prstGeom prst="rect">
+            <a:avLst/>
+          </a:prstGeom>
+        </p:spPr>
+      </p:pic>
+      <p:sp>
+        <p:nvSpPr>
+          <p:cNvPr id="17" name="Rounded Rectangle 16"/>
+          <p:cNvSpPr/>
+          <p:nvPr/>
+        </p:nvSpPr>
+        <p:spPr>
+          <a:xfrm>
+            <a:off x="8040000" y="900000"/>
+            <a:ext cx="3650000" cy="5450000"/>
+          </a:xfrm>
+          <a:prstGeom prst="roundRect">
+            <a:avLst/>
+          </a:prstGeom>
+          <a:solidFill>
+            <a:srgbClr val="FFFFFF"/>
+          </a:solidFill>
+          <a:ln>
+            <a:noFill/>
+          </a:ln>
+          <a:effectLst/>
+        </p:spPr>
+        <p:style>
+          <a:lnRef idx="1">
+            <a:schemeClr val="accent1"/>
+          </a:lnRef>
+          <a:fillRef idx="3">
+            <a:schemeClr val="accent1"/>
+          </a:fillRef>
+          <a:effectRef idx="2">
+            <a:schemeClr val="accent1"/>
+          </a:effectRef>
+          <a:fontRef idx="minor">
+            <a:schemeClr val="lt1"/>
+          </a:fontRef>
+        </p:style>
+        <p:txBody>
+          <a:bodyPr rtlCol="0" anchor="ctr"/>
+          <a:lstStyle/>
+          <a:p>
+            <a:pPr algn="ctr"/>
+          </a:p>
+        </p:txBody>
+      </p:sp>
+      <p:sp>
+        <p:nvSpPr>
+          <p:cNvPr id="18" name="Rectangle 17"/>
+          <p:cNvSpPr/>
+          <p:nvPr/>
+        </p:nvSpPr>
+        <p:spPr>
+          <a:xfrm>
+            <a:off x="8040000" y="900000"/>
+            <a:ext cx="3650000" cy="780000"/>
+          </a:xfrm>
+          <a:prstGeom prst="rect">
+            <a:avLst/>
+          </a:prstGeom>
+          <a:solidFill>
+            <a:srgbClr val="0B1F3A"/>
+          </a:solidFill>
+          <a:ln>
+            <a:noFill/>
+          </a:ln>
+          <a:effectLst/>
+        </p:spPr>
+        <p:style>
+          <a:lnRef idx="1">
+            <a:schemeClr val="accent1"/>
+          </a:lnRef>
+          <a:fillRef idx="3">
+            <a:schemeClr val="accent1"/>
+          </a:fillRef>
+          <a:effectRef idx="2">
+            <a:schemeClr val="accent1"/>
+          </a:effectRef>
+          <a:fontRef idx="minor">
+            <a:schemeClr val="lt1"/>
+          </a:fontRef>
+        </p:style>
+        <p:txBody>
+          <a:bodyPr rtlCol="0" anchor="ctr"/>
+          <a:lstStyle/>
+          <a:p>
+            <a:pPr algn="ctr"/>
+          </a:p>
+        </p:txBody>
+      </p:sp>
+      <p:sp>
+        <p:nvSpPr>
+          <p:cNvPr id="19" name="TextBox 18"/>
+          <p:cNvSpPr txBox="1"/>
+          <p:nvPr/>
+        </p:nvSpPr>
+        <p:spPr>
+          <a:xfrm>
+            <a:off x="8120000" y="990000"/>
+            <a:ext cx="3490000" cy="380000"/>
+          </a:xfrm>
+          <a:prstGeom prst="rect">
+            <a:avLst/>
+          </a:prstGeom>
+          <a:noFill/>
+        </p:spPr>
+        <p:txBody>
+          <a:bodyPr wrap="square" anchor="ctr">
+            <a:spAutoFit/>
+          </a:bodyPr>
+          <a:lstStyle/>
+          <a:p>
+            <a:pPr algn="ctr"/>
+            <a:r>
+              <a:rPr sz="2000" b="1" i="0">
+                <a:solidFill>
+                  <a:srgbClr val="FFFFFF"/>
+                </a:solidFill>
+                <a:latin typeface="Calibri"/>
+                <a:ea typeface="Calibri"/>
+                <a:cs typeface="Calibri"/>
+              </a:rPr>
+              <a:t>Микрообучение</a:t>
+            </a:r>
+          </a:p>
+        </p:txBody>
+      </p:sp>
+      <p:sp>
+        <p:nvSpPr>
+          <p:cNvPr id="20" name="TextBox 19"/>
+          <p:cNvSpPr txBox="1"/>
+          <p:nvPr/>
+        </p:nvSpPr>
+        <p:spPr>
+          <a:xfrm>
+            <a:off x="8120000" y="1330000"/>
+            <a:ext cx="3490000" cy="280000"/>
+          </a:xfrm>
+          <a:prstGeom prst="rect">
+            <a:avLst/>
+          </a:prstGeom>
+          <a:noFill/>
+        </p:spPr>
+        <p:txBody>
+          <a:bodyPr wrap="square" anchor="ctr">
+            <a:spAutoFit/>
+          </a:bodyPr>
+          <a:lstStyle/>
+          <a:p>
+            <a:pPr algn="ctr"/>
+            <a:r>
+              <a:rPr sz="1200" b="0" i="0">
+                <a:solidFill>
+                  <a:srgbClr val="B8C5D6"/>
+                </a:solidFill>
+                <a:latin typeface="Calibri"/>
+                <a:ea typeface="Calibri"/>
+                <a:cs typeface="Calibri"/>
+              </a:rPr>
+              <a:t>Диалог и выбор ответа</a:t>
+            </a:r>
+          </a:p>
+        </p:txBody>
+      </p:sp>
+      <p:pic>
+        <p:nvPicPr>
+          <p:cNvPr id="21" name="Picture 20" descr="blok-mikroobuchenie.png"/>
+          <p:cNvPicPr>
+            <a:picLocks noChangeAspect="1"/>
+          </p:cNvPicPr>
+          <p:nvPr/>
+        </p:nvPicPr>
+        <p:blipFill>
+          <a:blip r:embed="rId4"/>
+          <a:stretch>
+            <a:fillRect/>
+          </a:stretch>
+        </p:blipFill>
+        <p:spPr>
+          <a:xfrm>
+            <a:off x="8080000" y="1720000"/>
+            <a:ext cx="3570000" cy="4590000"/>
+          </a:xfrm>
+          <a:prstGeom prst="rect">
+            <a:avLst/>
+          </a:prstGeom>
+        </p:spPr>
+      </p:pic>
+      <p:sp>
+        <p:nvSpPr>
+          <p:cNvPr id="22" name="TextBox 21"/>
+          <p:cNvSpPr txBox="1"/>
+          <p:nvPr/>
+        </p:nvSpPr>
+        <p:spPr>
+          <a:xfrm>
+            <a:off x="457200" y="6565392"/>
+            <a:ext cx="8229600" cy="256032"/>
+          </a:xfrm>
+          <a:prstGeom prst="rect">
+            <a:avLst/>
+          </a:prstGeom>
+          <a:noFill/>
+        </p:spPr>
+        <p:txBody>
+          <a:bodyPr wrap="square" anchor="ctr">
+            <a:spAutoFit/>
+          </a:bodyPr>
+          <a:lstStyle/>
+          <a:p>
+            <a:pPr algn="l"/>
+            <a:r>
+              <a:rPr sz="1100" b="0" i="0">
+                <a:solidFill>
+                  <a:srgbClr val="9AA3B0"/>
+                </a:solidFill>
+                <a:latin typeface="Calibri"/>
+                <a:ea typeface="Calibri"/>
+                <a:cs typeface="Calibri"/>
+              </a:rPr>
+              <a:t>Lab-Интеллект  ·  СМАРТА  ·  конфиденциально</a:t>
+            </a:r>
+          </a:p>
+        </p:txBody>
+      </p:sp>
+    </p:spTree>
+  </p:cSld>
+  <p:clrMapOvr>
+    <a:masterClrMapping/>
+  </p:clrMapOvr>
+</p:sld>
+</file>
+
 <file path=ppt/slides/slide2.xml><?xml version="1.0" encoding="utf-8"?>
 <p:sld xmlns:a="http://schemas.openxmlformats.org/drawingml/2006/main" xmlns:r="http://schemas.openxmlformats.org/officeDocument/2006/relationships" xmlns:p="http://schemas.openxmlformats.org/presentationml/2006/main">
   <p:cSld>

</xml_diff>